<commit_message>
Slides: shorten sd-04-025..029 lines to the 10-word budget
Every text line of the five decks now holds at most 10 words, as
docs/sd101-slides-handoff.md asks; the PPTX files are re-exported
from the edited canvases (badge kept).

Co-Authored-By: Claude Opus 5.5 <noreply@anthropic.com>
Claude-Session: https://claude.ai/code/session_01JWtUsCyy9ESaq4agyTKnFb
</commit_message>
<xml_diff>
--- a/system-design-101/vi/lessons/sd-04-025/slides/sd-04-025.pptx
+++ b/system-design-101/vi/lessons/sd-04-025/slides/sd-04-025.pptx
@@ -3430,7 +3430,7 @@
                 <a:ea typeface="Be Vietnam Pro" pitchFamily="34" charset="-122"/>
                 <a:cs typeface="Be Vietnam Pro" pitchFamily="34" charset="-120"/>
               </a:rPr>
-              <a:t> biến</a:t>
+              <a:t> id</a:t>
             </a:r>
             <a:r>
               <a:rPr lang="en-US" sz="2550" dirty="0" spc="0" kern="0">
@@ -3441,7 +3441,7 @@
                 <a:ea typeface="Be Vietnam Pro" pitchFamily="34" charset="-122"/>
                 <a:cs typeface="Be Vietnam Pro" pitchFamily="34" charset="-120"/>
               </a:rPr>
-              <a:t> mỗi id thành</a:t>
+              <a:t> thành</a:t>
             </a:r>
             <a:r>
               <a:rPr lang="en-US" sz="2550" dirty="0" spc="-10" kern="0">
@@ -3453,17 +3453,6 @@
                 <a:cs typeface="Be Vietnam Pro" pitchFamily="34" charset="-120"/>
               </a:rPr>
               <a:t> số</a:t>
-            </a:r>
-            <a:r>
-              <a:rPr lang="en-US" sz="2550" dirty="0" spc="-16" kern="0">
-                <a:solidFill>
-                  <a:srgbClr val="F3EEE3"/>
-                </a:solidFill>
-                <a:latin typeface="Be Vietnam Pro" pitchFamily="34" charset="0"/>
-                <a:ea typeface="Be Vietnam Pro" pitchFamily="34" charset="-122"/>
-                <a:cs typeface="Be Vietnam Pro" pitchFamily="34" charset="-120"/>
-              </a:rPr>
-              <a:t> trông</a:t>
             </a:r>
             <a:r>
               <a:rPr lang="en-US" sz="2550" dirty="0" spc="-9" kern="0">
@@ -5079,6 +5068,50 @@
               <a:buNone/>
             </a:pPr>
             <a:r>
+              <a:rPr lang="en-US" sz="2700" dirty="0" spc="0" kern="0">
+                <a:solidFill>
+                  <a:srgbClr val="14161C"/>
+                </a:solidFill>
+                <a:latin typeface="Be Vietnam Pro" pitchFamily="34" charset="0"/>
+                <a:ea typeface="Be Vietnam Pro" pitchFamily="34" charset="-122"/>
+                <a:cs typeface="Be Vietnam Pro" pitchFamily="34" charset="-120"/>
+              </a:rPr>
+              <a:t>100.000</a:t>
+            </a:r>
+            <a:r>
+              <a:rPr lang="en-US" sz="2700" dirty="0" spc="-2" kern="0">
+                <a:solidFill>
+                  <a:srgbClr val="14161C"/>
+                </a:solidFill>
+                <a:latin typeface="Be Vietnam Pro" pitchFamily="34" charset="0"/>
+                <a:ea typeface="Be Vietnam Pro" pitchFamily="34" charset="-122"/>
+                <a:cs typeface="Be Vietnam Pro" pitchFamily="34" charset="-120"/>
+              </a:rPr>
+              <a:t> id</a:t>
+            </a:r>
+            <a:r>
+              <a:rPr lang="en-US" sz="2700" dirty="0" spc="-1" kern="0">
+                <a:solidFill>
+                  <a:srgbClr val="14161C"/>
+                </a:solidFill>
+                <a:latin typeface="Be Vietnam Pro" pitchFamily="34" charset="0"/>
+                <a:ea typeface="Be Vietnam Pro" pitchFamily="34" charset="-122"/>
+                <a:cs typeface="Be Vietnam Pro" pitchFamily="34" charset="-120"/>
+              </a:rPr>
+              <a:t> · từ</a:t>
+            </a:r>
+            <a:r>
+              <a:rPr lang="en-US" sz="2700" dirty="0" spc="0" kern="0">
+                <a:solidFill>
+                  <a:srgbClr val="14161C"/>
+                </a:solidFill>
+                <a:latin typeface="Be Vietnam Pro" pitchFamily="34" charset="0"/>
+                <a:ea typeface="Be Vietnam Pro" pitchFamily="34" charset="-122"/>
+                <a:cs typeface="Be Vietnam Pro" pitchFamily="34" charset="-120"/>
+              </a:rPr>
+              <a:t> 4</a:t>
+            </a:r>
+            <a:r>
               <a:rPr lang="en-US" sz="2700" dirty="0" spc="-3" kern="0">
                 <a:solidFill>
                   <a:srgbClr val="14161C"/>
@@ -5087,7 +5120,62 @@
                 <a:ea typeface="Be Vietnam Pro" pitchFamily="34" charset="-122"/>
                 <a:cs typeface="Be Vietnam Pro" pitchFamily="34" charset="-120"/>
               </a:rPr>
-              <a:t>Id</a:t>
+              <a:t> lên</a:t>
+            </a:r>
+            <a:r>
+              <a:rPr lang="en-US" sz="2700" dirty="0" spc="-4" kern="0">
+                <a:solidFill>
+                  <a:srgbClr val="14161C"/>
+                </a:solidFill>
+                <a:latin typeface="Be Vietnam Pro" pitchFamily="34" charset="0"/>
+                <a:ea typeface="Be Vietnam Pro" pitchFamily="34" charset="-122"/>
+                <a:cs typeface="Be Vietnam Pro" pitchFamily="34" charset="-120"/>
+              </a:rPr>
+              <a:t> 5</a:t>
+            </a:r>
+            <a:r>
+              <a:rPr lang="en-US" sz="2700" dirty="0" spc="-21" kern="0">
+                <a:solidFill>
+                  <a:srgbClr val="14161C"/>
+                </a:solidFill>
+                <a:latin typeface="Be Vietnam Pro" pitchFamily="34" charset="0"/>
+                <a:ea typeface="Be Vietnam Pro" pitchFamily="34" charset="-122"/>
+                <a:cs typeface="Be Vietnam Pro" pitchFamily="34" charset="-120"/>
+              </a:rPr>
+              <a:t> shard</a:t>
+            </a:r>
+            <a:r>
+              <a:rPr lang="en-US" sz="2700" dirty="0" spc="-2" kern="0">
+                <a:solidFill>
+                  <a:srgbClr val="14161C"/>
+                </a:solidFill>
+                <a:latin typeface="Be Vietnam Pro" pitchFamily="34" charset="0"/>
+                <a:ea typeface="Be Vietnam Pro" pitchFamily="34" charset="-122"/>
+                <a:cs typeface="Be Vietnam Pro" pitchFamily="34" charset="-120"/>
+              </a:rPr>
+              <a:t> ·</a:t>
+            </a:r>
+            <a:r>
+              <a:rPr lang="en-US" sz="2700" dirty="0" spc="11" kern="0">
+                <a:solidFill>
+                  <a:srgbClr val="14161C"/>
+                </a:solidFill>
+                <a:latin typeface="Be Vietnam Pro" pitchFamily="34" charset="0"/>
+                <a:ea typeface="Be Vietnam Pro" pitchFamily="34" charset="-122"/>
+                <a:cs typeface="Be Vietnam Pro" pitchFamily="34" charset="-120"/>
+              </a:rPr>
+              <a:t> đếm</a:t>
+            </a:r>
+            <a:r>
+              <a:rPr lang="en-US" sz="2700" dirty="0" spc="-6" kern="0">
+                <a:solidFill>
+                  <a:srgbClr val="14161C"/>
+                </a:solidFill>
+                <a:latin typeface="Be Vietnam Pro" pitchFamily="34" charset="0"/>
+                <a:ea typeface="Be Vietnam Pro" pitchFamily="34" charset="-122"/>
+                <a:cs typeface="Be Vietnam Pro" pitchFamily="34" charset="-120"/>
+              </a:rPr>
+              <a:t> khóa</a:t>
             </a:r>
             <a:r>
               <a:rPr lang="en-US" sz="2700" dirty="0" spc="-1" kern="0">
@@ -5098,150 +5186,7 @@
                 <a:ea typeface="Be Vietnam Pro" pitchFamily="34" charset="-122"/>
                 <a:cs typeface="Be Vietnam Pro" pitchFamily="34" charset="-120"/>
               </a:rPr>
-              <a:t> 1</a:t>
-            </a:r>
-            <a:r>
-              <a:rPr lang="en-US" sz="2700" dirty="0" spc="10" kern="0">
-                <a:solidFill>
-                  <a:srgbClr val="14161C"/>
-                </a:solidFill>
-                <a:latin typeface="Be Vietnam Pro" pitchFamily="34" charset="0"/>
-                <a:ea typeface="Be Vietnam Pro" pitchFamily="34" charset="-122"/>
-                <a:cs typeface="Be Vietnam Pro" pitchFamily="34" charset="-120"/>
-              </a:rPr>
-              <a:t> đến</a:t>
-            </a:r>
-            <a:r>
-              <a:rPr lang="en-US" sz="2700" dirty="0" spc="0" kern="0">
-                <a:solidFill>
-                  <a:srgbClr val="14161C"/>
-                </a:solidFill>
-                <a:latin typeface="Be Vietnam Pro" pitchFamily="34" charset="0"/>
-                <a:ea typeface="Be Vietnam Pro" pitchFamily="34" charset="-122"/>
-                <a:cs typeface="Be Vietnam Pro" pitchFamily="34" charset="-120"/>
-              </a:rPr>
-              <a:t> 100.000</a:t>
-            </a:r>
-            <a:r>
-              <a:rPr lang="en-US" sz="2700" dirty="0" spc="-3" kern="0">
-                <a:solidFill>
-                  <a:srgbClr val="14161C"/>
-                </a:solidFill>
-                <a:latin typeface="Be Vietnam Pro" pitchFamily="34" charset="0"/>
-                <a:ea typeface="Be Vietnam Pro" pitchFamily="34" charset="-122"/>
-                <a:cs typeface="Be Vietnam Pro" pitchFamily="34" charset="-120"/>
-              </a:rPr>
-              <a:t> ·</a:t>
-            </a:r>
-            <a:r>
-              <a:rPr lang="en-US" sz="2700" dirty="0" spc="1" kern="0">
-                <a:solidFill>
-                  <a:srgbClr val="14161C"/>
-                </a:solidFill>
-                <a:latin typeface="Be Vietnam Pro" pitchFamily="34" charset="0"/>
-                <a:ea typeface="Be Vietnam Pro" pitchFamily="34" charset="-122"/>
-                <a:cs typeface="Be Vietnam Pro" pitchFamily="34" charset="-120"/>
-              </a:rPr>
-              <a:t> 4</a:t>
-            </a:r>
-            <a:r>
-              <a:rPr lang="en-US" sz="2700" dirty="0" spc="-21" kern="0">
-                <a:solidFill>
-                  <a:srgbClr val="14161C"/>
-                </a:solidFill>
-                <a:latin typeface="Be Vietnam Pro" pitchFamily="34" charset="0"/>
-                <a:ea typeface="Be Vietnam Pro" pitchFamily="34" charset="-122"/>
-                <a:cs typeface="Be Vietnam Pro" pitchFamily="34" charset="-120"/>
-              </a:rPr>
-              <a:t> shard</a:t>
-            </a:r>
-            <a:r>
-              <a:rPr lang="en-US" sz="2700" dirty="0" spc="-2" kern="0">
-                <a:solidFill>
-                  <a:srgbClr val="14161C"/>
-                </a:solidFill>
-                <a:latin typeface="Be Vietnam Pro" pitchFamily="34" charset="0"/>
-                <a:ea typeface="Be Vietnam Pro" pitchFamily="34" charset="-122"/>
-                <a:cs typeface="Be Vietnam Pro" pitchFamily="34" charset="-120"/>
-              </a:rPr>
-              <a:t> thêm</a:t>
-            </a:r>
-            <a:r>
-              <a:rPr lang="en-US" sz="2700" dirty="0" spc="-21" kern="0">
-                <a:solidFill>
-                  <a:srgbClr val="14161C"/>
-                </a:solidFill>
-                <a:latin typeface="Be Vietnam Pro" pitchFamily="34" charset="0"/>
-                <a:ea typeface="Be Vietnam Pro" pitchFamily="34" charset="-122"/>
-                <a:cs typeface="Be Vietnam Pro" pitchFamily="34" charset="-120"/>
-              </a:rPr>
-              <a:t> shard</a:t>
-            </a:r>
-            <a:r>
-              <a:rPr lang="en-US" sz="2700" dirty="0" spc="0" kern="0">
-                <a:solidFill>
-                  <a:srgbClr val="14161C"/>
-                </a:solidFill>
-                <a:latin typeface="Be Vietnam Pro" pitchFamily="34" charset="0"/>
-                <a:ea typeface="Be Vietnam Pro" pitchFamily="34" charset="-122"/>
-                <a:cs typeface="Be Vietnam Pro" pitchFamily="34" charset="-120"/>
-              </a:rPr>
-              <a:t> thứ</a:t>
-            </a:r>
-            <a:r>
-              <a:rPr lang="en-US" sz="2700" dirty="0" spc="-2" kern="0">
-                <a:solidFill>
-                  <a:srgbClr val="14161C"/>
-                </a:solidFill>
-                <a:latin typeface="Be Vietnam Pro" pitchFamily="34" charset="0"/>
-                <a:ea typeface="Be Vietnam Pro" pitchFamily="34" charset="-122"/>
-                <a:cs typeface="Be Vietnam Pro" pitchFamily="34" charset="-120"/>
-              </a:rPr>
-              <a:t> năm ·</a:t>
-            </a:r>
-            <a:r>
-              <a:rPr lang="en-US" sz="2700" dirty="0" spc="11" kern="0">
-                <a:solidFill>
-                  <a:srgbClr val="14161C"/>
-                </a:solidFill>
-                <a:latin typeface="Be Vietnam Pro" pitchFamily="34" charset="0"/>
-                <a:ea typeface="Be Vietnam Pro" pitchFamily="34" charset="-122"/>
-                <a:cs typeface="Be Vietnam Pro" pitchFamily="34" charset="-120"/>
-              </a:rPr>
-              <a:t> đếm</a:t>
-            </a:r>
-            <a:r>
-              <a:rPr lang="en-US" sz="2700" dirty="0" spc="-6" kern="0">
-                <a:solidFill>
-                  <a:srgbClr val="14161C"/>
-                </a:solidFill>
-                <a:latin typeface="Be Vietnam Pro" pitchFamily="34" charset="0"/>
-                <a:ea typeface="Be Vietnam Pro" pitchFamily="34" charset="-122"/>
-                <a:cs typeface="Be Vietnam Pro" pitchFamily="34" charset="-120"/>
-              </a:rPr>
-              <a:t> khóa</a:t>
-            </a:r>
-            <a:r>
-              <a:rPr lang="en-US" sz="2700" dirty="0" spc="13" kern="0">
-                <a:solidFill>
-                  <a:srgbClr val="14161C"/>
-                </a:solidFill>
-                <a:latin typeface="Be Vietnam Pro" pitchFamily="34" charset="0"/>
-                <a:ea typeface="Be Vietnam Pro" pitchFamily="34" charset="-122"/>
-                <a:cs typeface="Be Vietnam Pro" pitchFamily="34" charset="-120"/>
-              </a:rPr>
-              <a:t> đổi</a:t>
-            </a:r>
-            <a:r>
-              <a:rPr lang="en-US" sz="2700" dirty="0" spc="-21" kern="0">
-                <a:solidFill>
-                  <a:srgbClr val="14161C"/>
-                </a:solidFill>
-                <a:latin typeface="Be Vietnam Pro" pitchFamily="34" charset="0"/>
-                <a:ea typeface="Be Vietnam Pro" pitchFamily="34" charset="-122"/>
-                <a:cs typeface="Be Vietnam Pro" pitchFamily="34" charset="-120"/>
-              </a:rPr>
-              <a:t> shard</a:t>
+              <a:t> dời</a:t>
             </a:r>
             <a:endParaRPr lang="en-US" sz="2700" dirty="0"/>
           </a:p>
@@ -5361,28 +5306,6 @@
             </a:r>
             <a:r>
               <a:rPr lang="en-US" sz="2100" dirty="0" spc="0" kern="0">
-                <a:solidFill>
-                  <a:srgbClr val="6B6A66"/>
-                </a:solidFill>
-                <a:latin typeface="Be Vietnam Pro" pitchFamily="34" charset="0"/>
-                <a:ea typeface="Be Vietnam Pro" pitchFamily="34" charset="-122"/>
-                <a:cs typeface="Be Vietnam Pro" pitchFamily="34" charset="-120"/>
-              </a:rPr>
-              <a:t> của</a:t>
-            </a:r>
-            <a:r>
-              <a:rPr lang="en-US" sz="2100" dirty="0" spc="-8" kern="0">
-                <a:solidFill>
-                  <a:srgbClr val="6B6A66"/>
-                </a:solidFill>
-                <a:latin typeface="Be Vietnam Pro" pitchFamily="34" charset="0"/>
-                <a:ea typeface="Be Vietnam Pro" pitchFamily="34" charset="-122"/>
-                <a:cs typeface="Be Vietnam Pro" pitchFamily="34" charset="-120"/>
-              </a:rPr>
-              <a:t> một</a:t>
-            </a:r>
-            <a:r>
-              <a:rPr lang="en-US" sz="2100" dirty="0" spc="-1" kern="0">
                 <a:solidFill>
                   <a:srgbClr val="6B6A66"/>
                 </a:solidFill>
@@ -7045,17 +6968,6 @@
               <a:t>Id</a:t>
             </a:r>
             <a:r>
-              <a:rPr lang="en-US" sz="2700" dirty="0" spc="0" kern="0">
-                <a:solidFill>
-                  <a:srgbClr val="14161C"/>
-                </a:solidFill>
-                <a:latin typeface="Be Vietnam Pro" pitchFamily="34" charset="0"/>
-                <a:ea typeface="Be Vietnam Pro" pitchFamily="34" charset="-122"/>
-                <a:cs typeface="Be Vietnam Pro" pitchFamily="34" charset="-120"/>
-              </a:rPr>
-              <a:t> cấp</a:t>
-            </a:r>
-            <a:r>
               <a:rPr lang="en-US" sz="2700" dirty="0" spc="-11" kern="0">
                 <a:solidFill>
                   <a:srgbClr val="14161C"/>
@@ -7097,10 +7009,21 @@
                 <a:ea typeface="Be Vietnam Pro" pitchFamily="34" charset="-122"/>
                 <a:cs typeface="Be Vietnam Pro" pitchFamily="34" charset="-120"/>
               </a:rPr>
-              <a:t> id mới</a:t>
-            </a:r>
-            <a:r>
-              <a:rPr lang="en-US" sz="2700" dirty="0" spc="12" kern="0">
+              <a:t> id</a:t>
+            </a:r>
+            <a:r>
+              <a:rPr lang="en-US" sz="2700" dirty="0" spc="-1" kern="0">
+                <a:solidFill>
+                  <a:srgbClr val="14161C"/>
+                </a:solidFill>
+                <a:latin typeface="Be Vietnam Pro" pitchFamily="34" charset="0"/>
+                <a:ea typeface="Be Vietnam Pro" pitchFamily="34" charset="-122"/>
+                <a:cs typeface="Be Vietnam Pro" pitchFamily="34" charset="-120"/>
+              </a:rPr>
+              <a:t> mới</a:t>
+            </a:r>
+            <a:r>
+              <a:rPr lang="en-US" sz="2700" dirty="0" spc="11" kern="0">
                 <a:solidFill>
                   <a:srgbClr val="14161C"/>
                 </a:solidFill>
@@ -8836,62 +8759,7 @@
                 <a:ea typeface="Be Vietnam Pro" pitchFamily="34" charset="-122"/>
                 <a:cs typeface="Be Vietnam Pro" pitchFamily="34" charset="-120"/>
               </a:rPr>
-              <a:t> yên:</a:t>
-            </a:r>
-            <a:r>
-              <a:rPr lang="en-US" sz="2700" dirty="0" spc="-2" kern="0">
-                <a:solidFill>
-                  <a:srgbClr val="E4E1D8"/>
-                </a:solidFill>
-                <a:latin typeface="Be Vietnam Pro" pitchFamily="34" charset="0"/>
-                <a:ea typeface="Be Vietnam Pro" pitchFamily="34" charset="-122"/>
-                <a:cs typeface="Be Vietnam Pro" pitchFamily="34" charset="-120"/>
-              </a:rPr>
-              <a:t> hai</a:t>
-            </a:r>
-            <a:r>
-              <a:rPr lang="en-US" sz="2700" dirty="0" spc="-3" kern="0">
-                <a:solidFill>
-                  <a:srgbClr val="E4E1D8"/>
-                </a:solidFill>
-                <a:latin typeface="Be Vietnam Pro" pitchFamily="34" charset="0"/>
-                <a:ea typeface="Be Vietnam Pro" pitchFamily="34" charset="-122"/>
-                <a:cs typeface="Be Vietnam Pro" pitchFamily="34" charset="-120"/>
-              </a:rPr>
-              <a:t> phép</a:t>
-            </a:r>
-            <a:r>
-              <a:rPr lang="en-US" sz="2700" dirty="0" spc="-1" kern="0">
-                <a:solidFill>
-                  <a:srgbClr val="E4E1D8"/>
-                </a:solidFill>
-                <a:latin typeface="Be Vietnam Pro" pitchFamily="34" charset="0"/>
-                <a:ea typeface="Be Vietnam Pro" pitchFamily="34" charset="-122"/>
-                <a:cs typeface="Be Vietnam Pro" pitchFamily="34" charset="-120"/>
-              </a:rPr>
-              <a:t> chia</a:t>
-            </a:r>
-            <a:r>
-              <a:rPr lang="en-US" sz="2700" dirty="0" spc="0" kern="0">
-                <a:solidFill>
-                  <a:srgbClr val="E4E1D8"/>
-                </a:solidFill>
-                <a:latin typeface="Be Vietnam Pro" pitchFamily="34" charset="0"/>
-                <a:ea typeface="Be Vietnam Pro" pitchFamily="34" charset="-122"/>
-                <a:cs typeface="Be Vietnam Pro" pitchFamily="34" charset="-120"/>
-              </a:rPr>
-              <a:t> dư</a:t>
-            </a:r>
-            <a:r>
-              <a:rPr lang="en-US" sz="2700" dirty="0" spc="-2" kern="0">
-                <a:solidFill>
-                  <a:srgbClr val="E4E1D8"/>
-                </a:solidFill>
-                <a:latin typeface="Be Vietnam Pro" pitchFamily="34" charset="0"/>
-                <a:ea typeface="Be Vietnam Pro" pitchFamily="34" charset="-122"/>
-                <a:cs typeface="Be Vietnam Pro" pitchFamily="34" charset="-120"/>
-              </a:rPr>
-              <a:t> trùng nhau.</a:t>
+              <a:t> yên.</a:t>
             </a:r>
             <a:endParaRPr lang="en-US" sz="2700" dirty="0"/>
           </a:p>
@@ -10450,7 +10318,7 @@
               <a:buNone/>
             </a:pPr>
             <a:r>
-              <a:rPr lang="en-US" sz="2100" dirty="0" spc="-12" kern="0">
+              <a:rPr lang="en-US" sz="2100" dirty="0" spc="-10" kern="0">
                 <a:solidFill>
                   <a:srgbClr val="6B6A66"/>
                 </a:solidFill>
@@ -10458,10 +10326,10 @@
                 <a:ea typeface="Be Vietnam Pro" pitchFamily="34" charset="-122"/>
                 <a:cs typeface="Be Vietnam Pro" pitchFamily="34" charset="-120"/>
               </a:rPr>
-              <a:t>Cassandra</a:t>
-            </a:r>
-            <a:r>
-              <a:rPr lang="en-US" sz="2100" dirty="0" spc="-11" kern="0">
+              <a:t>Cassandra:</a:t>
+            </a:r>
+            <a:r>
+              <a:rPr lang="en-US" sz="2100" dirty="0" spc="-3" kern="0">
                 <a:solidFill>
                   <a:srgbClr val="6B6A66"/>
                 </a:solidFill>
@@ -10469,10 +10337,10 @@
                 <a:ea typeface="Be Vietnam Pro" pitchFamily="34" charset="-122"/>
                 <a:cs typeface="Be Vietnam Pro" pitchFamily="34" charset="-120"/>
               </a:rPr>
-              <a:t> gọi</a:t>
-            </a:r>
-            <a:r>
-              <a:rPr lang="en-US" sz="2100" dirty="0" spc="18" kern="0">
+              <a:t> cấu</a:t>
+            </a:r>
+            <a:r>
+              <a:rPr lang="en-US" sz="2100" dirty="0" spc="1" kern="0">
                 <a:solidFill>
                   <a:srgbClr val="6B6A66"/>
                 </a:solidFill>
@@ -10480,10 +10348,10 @@
                 <a:ea typeface="Be Vietnam Pro" pitchFamily="34" charset="-122"/>
                 <a:cs typeface="Be Vietnam Pro" pitchFamily="34" charset="-120"/>
               </a:rPr>
-              <a:t> điểm</a:t>
-            </a:r>
-            <a:r>
-              <a:rPr lang="en-US" sz="2100" dirty="0" spc="-3" kern="0">
+              <a:t> hình</a:t>
+            </a:r>
+            <a:r>
+              <a:rPr lang="en-US" sz="2100" dirty="0" spc="-2" kern="0">
                 <a:solidFill>
                   <a:srgbClr val="6B6A66"/>
                 </a:solidFill>
@@ -10491,10 +10359,10 @@
                 <a:ea typeface="Be Vietnam Pro" pitchFamily="34" charset="-122"/>
                 <a:cs typeface="Be Vietnam Pro" pitchFamily="34" charset="-120"/>
               </a:rPr>
-              <a:t> là</a:t>
-            </a:r>
-            <a:r>
-              <a:rPr lang="en-US" sz="2100" dirty="0" spc="-20" kern="0">
+              <a:t> mẫu đặt</a:t>
+            </a:r>
+            <a:r>
+              <a:rPr lang="en-US" sz="2100" dirty="0" spc="-1" kern="0">
                 <a:solidFill>
                   <a:srgbClr val="6B6A66"/>
                 </a:solidFill>
@@ -10502,10 +10370,10 @@
                 <a:ea typeface="Be Vietnam Pro" pitchFamily="34" charset="-122"/>
                 <a:cs typeface="Be Vietnam Pro" pitchFamily="34" charset="-120"/>
               </a:rPr>
-              <a:t> token;</a:t>
-            </a:r>
-            <a:r>
-              <a:rPr lang="en-US" sz="2100" dirty="0" spc="-3" kern="0">
+              <a:t> 16</a:t>
+            </a:r>
+            <a:r>
+              <a:rPr lang="en-US" sz="2100" dirty="0" spc="-24" kern="0">
                 <a:solidFill>
                   <a:srgbClr val="6B6A66"/>
                 </a:solidFill>
@@ -10513,10 +10381,10 @@
                 <a:ea typeface="Be Vietnam Pro" pitchFamily="34" charset="-122"/>
                 <a:cs typeface="Be Vietnam Pro" pitchFamily="34" charset="-120"/>
               </a:rPr>
-              <a:t> cấu</a:t>
-            </a:r>
-            <a:r>
-              <a:rPr lang="en-US" sz="2100" dirty="0" spc="1" kern="0">
+              <a:t> token</a:t>
+            </a:r>
+            <a:r>
+              <a:rPr lang="en-US" sz="2100" dirty="0" spc="-1" kern="0">
                 <a:solidFill>
                   <a:srgbClr val="6B6A66"/>
                 </a:solidFill>
@@ -10524,10 +10392,10 @@
                 <a:ea typeface="Be Vietnam Pro" pitchFamily="34" charset="-122"/>
                 <a:cs typeface="Be Vietnam Pro" pitchFamily="34" charset="-120"/>
               </a:rPr>
-              <a:t> hình</a:t>
-            </a:r>
-            <a:r>
-              <a:rPr lang="en-US" sz="2100" dirty="0" spc="-2" kern="0">
+              <a:t> mỗi</a:t>
+            </a:r>
+            <a:r>
+              <a:rPr lang="en-US" sz="2100" dirty="0" spc="-10" kern="0">
                 <a:solidFill>
                   <a:srgbClr val="6B6A66"/>
                 </a:solidFill>
@@ -10535,51 +10403,7 @@
                 <a:ea typeface="Be Vietnam Pro" pitchFamily="34" charset="-122"/>
                 <a:cs typeface="Be Vietnam Pro" pitchFamily="34" charset="-120"/>
               </a:rPr>
-              <a:t> mẫu đặt</a:t>
-            </a:r>
-            <a:r>
-              <a:rPr lang="en-US" sz="2100" dirty="0" spc="-1" kern="0">
-                <a:solidFill>
-                  <a:srgbClr val="6B6A66"/>
-                </a:solidFill>
-                <a:latin typeface="Be Vietnam Pro" pitchFamily="34" charset="0"/>
-                <a:ea typeface="Be Vietnam Pro" pitchFamily="34" charset="-122"/>
-                <a:cs typeface="Be Vietnam Pro" pitchFamily="34" charset="-120"/>
-              </a:rPr>
-              <a:t> 16</a:t>
-            </a:r>
-            <a:r>
-              <a:rPr lang="en-US" sz="2100" dirty="0" spc="-24" kern="0">
-                <a:solidFill>
-                  <a:srgbClr val="6B6A66"/>
-                </a:solidFill>
-                <a:latin typeface="Be Vietnam Pro" pitchFamily="34" charset="0"/>
-                <a:ea typeface="Be Vietnam Pro" pitchFamily="34" charset="-122"/>
-                <a:cs typeface="Be Vietnam Pro" pitchFamily="34" charset="-120"/>
-              </a:rPr>
-              <a:t> token</a:t>
-            </a:r>
-            <a:r>
-              <a:rPr lang="en-US" sz="2100" dirty="0" spc="-1" kern="0">
-                <a:solidFill>
-                  <a:srgbClr val="6B6A66"/>
-                </a:solidFill>
-                <a:latin typeface="Be Vietnam Pro" pitchFamily="34" charset="0"/>
-                <a:ea typeface="Be Vietnam Pro" pitchFamily="34" charset="-122"/>
-                <a:cs typeface="Be Vietnam Pro" pitchFamily="34" charset="-120"/>
-              </a:rPr>
-              <a:t> mỗi</a:t>
-            </a:r>
-            <a:r>
-              <a:rPr lang="en-US" sz="2100" dirty="0" spc="-8" kern="0">
-                <a:solidFill>
-                  <a:srgbClr val="6B6A66"/>
-                </a:solidFill>
-                <a:latin typeface="Be Vietnam Pro" pitchFamily="34" charset="0"/>
-                <a:ea typeface="Be Vietnam Pro" pitchFamily="34" charset="-122"/>
-                <a:cs typeface="Be Vietnam Pro" pitchFamily="34" charset="-120"/>
-              </a:rPr>
-              <a:t> máy.</a:t>
+              <a:t> máy</a:t>
             </a:r>
             <a:endParaRPr lang="en-US" sz="2100" dirty="0"/>
           </a:p>
@@ -13228,10 +13052,10 @@
                 <a:ea typeface="Be Vietnam Pro" pitchFamily="34" charset="-122"/>
                 <a:cs typeface="Be Vietnam Pro" pitchFamily="34" charset="-120"/>
               </a:rPr>
-              <a:t>Phép</a:t>
-            </a:r>
-            <a:r>
-              <a:rPr lang="en-US" sz="2850" dirty="0" spc="-1" kern="0">
+              <a:t>Chỉ</a:t>
+            </a:r>
+            <a:r>
+              <a:rPr lang="en-US" sz="2850" dirty="0" spc="14" kern="0">
                 <a:solidFill>
                   <a:srgbClr val="F3EEE3"/>
                 </a:solidFill>
@@ -13239,10 +13063,10 @@
                 <a:ea typeface="Be Vietnam Pro" pitchFamily="34" charset="-122"/>
                 <a:cs typeface="Be Vietnam Pro" pitchFamily="34" charset="-120"/>
               </a:rPr>
-              <a:t> thử</a:t>
-            </a:r>
-            <a:r>
-              <a:rPr lang="en-US" sz="2850" dirty="0" spc="13" kern="0">
+              <a:t> đếm</a:t>
+            </a:r>
+            <a:r>
+              <a:rPr lang="en-US" sz="2850" dirty="0" spc="-2" kern="0">
                 <a:solidFill>
                   <a:srgbClr val="F3EEE3"/>
                 </a:solidFill>
@@ -13250,10 +13074,10 @@
                 <a:ea typeface="Be Vietnam Pro" pitchFamily="34" charset="-122"/>
                 <a:cs typeface="Be Vietnam Pro" pitchFamily="34" charset="-120"/>
               </a:rPr>
-              <a:t> đếm</a:t>
-            </a:r>
-            <a:r>
-              <a:rPr lang="en-US" sz="2850" dirty="0" spc="-2" kern="0">
+              <a:t> khóa,</a:t>
+            </a:r>
+            <a:r>
+              <a:rPr lang="en-US" sz="2850" dirty="0" spc="-3" kern="0">
                 <a:solidFill>
                   <a:srgbClr val="F3EEE3"/>
                 </a:solidFill>
@@ -13261,10 +13085,10 @@
                 <a:ea typeface="Be Vietnam Pro" pitchFamily="34" charset="-122"/>
                 <a:cs typeface="Be Vietnam Pro" pitchFamily="34" charset="-120"/>
               </a:rPr>
-              <a:t> khóa, không</a:t>
-            </a:r>
-            <a:r>
-              <a:rPr lang="en-US" sz="2850" dirty="0" spc="21" kern="0">
+              <a:t> không</a:t>
+            </a:r>
+            <a:r>
+              <a:rPr lang="en-US" sz="2850" dirty="0" spc="22" kern="0">
                 <a:solidFill>
                   <a:srgbClr val="F3EEE3"/>
                 </a:solidFill>
@@ -13347,7 +13171,7 @@
               <a:buNone/>
             </a:pPr>
             <a:r>
-              <a:rPr lang="en-US" sz="2850" dirty="0" spc="-11" kern="0">
+              <a:rPr lang="en-US" sz="2850" dirty="0" spc="-4" kern="0">
                 <a:solidFill>
                   <a:srgbClr val="F3EEE3"/>
                 </a:solidFill>
@@ -13355,7 +13179,7 @@
                 <a:ea typeface="Be Vietnam Pro" pitchFamily="34" charset="-122"/>
                 <a:cs typeface="Be Vietnam Pro" pitchFamily="34" charset="-120"/>
               </a:rPr>
-              <a:t>Một</a:t>
+              <a:t>Khóa</a:t>
             </a:r>
             <a:r>
               <a:rPr lang="en-US" sz="2850" dirty="0" spc="-3" kern="0">
@@ -13366,10 +13190,10 @@
                 <a:ea typeface="Be Vietnam Pro" pitchFamily="34" charset="-122"/>
                 <a:cs typeface="Be Vietnam Pro" pitchFamily="34" charset="-120"/>
               </a:rPr>
-              <a:t> khóa</a:t>
-            </a:r>
-            <a:r>
-              <a:rPr lang="en-US" sz="2850" dirty="0" spc="-2" kern="0">
+              <a:t> nóng</a:t>
+            </a:r>
+            <a:r>
+              <a:rPr lang="en-US" sz="2850" dirty="0" spc="-13" kern="0">
                 <a:solidFill>
                   <a:srgbClr val="F3EEE3"/>
                 </a:solidFill>
@@ -13377,7 +13201,18 @@
                 <a:ea typeface="Be Vietnam Pro" pitchFamily="34" charset="-122"/>
                 <a:cs typeface="Be Vietnam Pro" pitchFamily="34" charset="-120"/>
               </a:rPr>
-              <a:t> nóng</a:t>
+              <a:t> vẫn</a:t>
+            </a:r>
+            <a:r>
+              <a:rPr lang="en-US" sz="2850" dirty="0" spc="0" kern="0">
+                <a:solidFill>
+                  <a:srgbClr val="F3EEE3"/>
+                </a:solidFill>
+                <a:latin typeface="Be Vietnam Pro" pitchFamily="34" charset="0"/>
+                <a:ea typeface="Be Vietnam Pro" pitchFamily="34" charset="-122"/>
+                <a:cs typeface="Be Vietnam Pro" pitchFamily="34" charset="-120"/>
+              </a:rPr>
+              <a:t> quá</a:t>
             </a:r>
             <a:r>
               <a:rPr lang="en-US" sz="2850" dirty="0" spc="-14" kern="0">
@@ -13388,10 +13223,10 @@
                 <a:ea typeface="Be Vietnam Pro" pitchFamily="34" charset="-122"/>
                 <a:cs typeface="Be Vietnam Pro" pitchFamily="34" charset="-120"/>
               </a:rPr>
-              <a:t> vẫn</a:t>
-            </a:r>
-            <a:r>
-              <a:rPr lang="en-US" sz="2850" dirty="0" spc="0" kern="0">
+              <a:t> tải</a:t>
+            </a:r>
+            <a:r>
+              <a:rPr lang="en-US" sz="2850" dirty="0" spc="-15" kern="0">
                 <a:solidFill>
                   <a:srgbClr val="F3EEE3"/>
                 </a:solidFill>
@@ -13399,10 +13234,10 @@
                 <a:ea typeface="Be Vietnam Pro" pitchFamily="34" charset="-122"/>
                 <a:cs typeface="Be Vietnam Pro" pitchFamily="34" charset="-120"/>
               </a:rPr>
-              <a:t> quá</a:t>
-            </a:r>
-            <a:r>
-              <a:rPr lang="en-US" sz="2850" dirty="0" spc="-14" kern="0">
+              <a:t> shard,</a:t>
+            </a:r>
+            <a:r>
+              <a:rPr lang="en-US" sz="2850" dirty="0" spc="-1" kern="0">
                 <a:solidFill>
                   <a:srgbClr val="F3EEE3"/>
                 </a:solidFill>
@@ -13410,10 +13245,10 @@
                 <a:ea typeface="Be Vietnam Pro" pitchFamily="34" charset="-122"/>
                 <a:cs typeface="Be Vietnam Pro" pitchFamily="34" charset="-120"/>
               </a:rPr>
-              <a:t> tải</a:t>
-            </a:r>
-            <a:r>
-              <a:rPr lang="en-US" sz="2850" dirty="0" spc="-15" kern="0">
+              <a:t> dù</a:t>
+            </a:r>
+            <a:r>
+              <a:rPr lang="en-US" sz="2850" dirty="0" spc="2" kern="0">
                 <a:solidFill>
                   <a:srgbClr val="F3EEE3"/>
                 </a:solidFill>
@@ -13421,10 +13256,10 @@
                 <a:ea typeface="Be Vietnam Pro" pitchFamily="34" charset="-122"/>
                 <a:cs typeface="Be Vietnam Pro" pitchFamily="34" charset="-120"/>
               </a:rPr>
-              <a:t> shard,</a:t>
-            </a:r>
-            <a:r>
-              <a:rPr lang="en-US" sz="2850" dirty="0" spc="0" kern="0">
+              <a:t> chia</a:t>
+            </a:r>
+            <a:r>
+              <a:rPr lang="en-US" sz="2850" dirty="0" spc="-1" kern="0">
                 <a:solidFill>
                   <a:srgbClr val="F3EEE3"/>
                 </a:solidFill>
@@ -13432,32 +13267,10 @@
                 <a:ea typeface="Be Vietnam Pro" pitchFamily="34" charset="-122"/>
                 <a:cs typeface="Be Vietnam Pro" pitchFamily="34" charset="-120"/>
               </a:rPr>
-              <a:t> dù</a:t>
+              <a:t> cách</a:t>
             </a:r>
             <a:r>
               <a:rPr lang="en-US" sz="2850" dirty="0" spc="2" kern="0">
-                <a:solidFill>
-                  <a:srgbClr val="F3EEE3"/>
-                </a:solidFill>
-                <a:latin typeface="Be Vietnam Pro" pitchFamily="34" charset="0"/>
-                <a:ea typeface="Be Vietnam Pro" pitchFamily="34" charset="-122"/>
-                <a:cs typeface="Be Vietnam Pro" pitchFamily="34" charset="-120"/>
-              </a:rPr>
-              <a:t> chia</a:t>
-            </a:r>
-            <a:r>
-              <a:rPr lang="en-US" sz="2850" dirty="0" spc="-1" kern="0">
-                <a:solidFill>
-                  <a:srgbClr val="F3EEE3"/>
-                </a:solidFill>
-                <a:latin typeface="Be Vietnam Pro" pitchFamily="34" charset="0"/>
-                <a:ea typeface="Be Vietnam Pro" pitchFamily="34" charset="-122"/>
-                <a:cs typeface="Be Vietnam Pro" pitchFamily="34" charset="-120"/>
-              </a:rPr>
-              <a:t> cách</a:t>
-            </a:r>
-            <a:r>
-              <a:rPr lang="en-US" sz="2850" dirty="0" spc="1" kern="0">
                 <a:solidFill>
                   <a:srgbClr val="F3EEE3"/>
                 </a:solidFill>
@@ -13507,6 +13320,28 @@
               <a:t>Băm</a:t>
             </a:r>
             <a:r>
+              <a:rPr lang="en-US" sz="2850" dirty="0" spc="-16" kern="0">
+                <a:solidFill>
+                  <a:srgbClr val="F3EEE3"/>
+                </a:solidFill>
+                <a:latin typeface="Be Vietnam Pro" pitchFamily="34" charset="0"/>
+                <a:ea typeface="Be Vietnam Pro" pitchFamily="34" charset="-122"/>
+                <a:cs typeface="Be Vietnam Pro" pitchFamily="34" charset="-120"/>
+              </a:rPr>
+              <a:t> mất</a:t>
+            </a:r>
+            <a:r>
+              <a:rPr lang="en-US" sz="2850" dirty="0" spc="-1" kern="0">
+                <a:solidFill>
+                  <a:srgbClr val="F3EEE3"/>
+                </a:solidFill>
+                <a:latin typeface="Be Vietnam Pro" pitchFamily="34" charset="0"/>
+                <a:ea typeface="Be Vietnam Pro" pitchFamily="34" charset="-122"/>
+                <a:cs typeface="Be Vietnam Pro" pitchFamily="34" charset="-120"/>
+              </a:rPr>
+              <a:t> thứ</a:t>
+            </a:r>
+            <a:r>
               <a:rPr lang="en-US" sz="2850" dirty="0" spc="0" kern="0">
                 <a:solidFill>
                   <a:srgbClr val="F3EEE3"/>
@@ -13515,10 +13350,10 @@
                 <a:ea typeface="Be Vietnam Pro" pitchFamily="34" charset="-122"/>
                 <a:cs typeface="Be Vietnam Pro" pitchFamily="34" charset="-120"/>
               </a:rPr>
-              <a:t> làm</a:t>
-            </a:r>
-            <a:r>
-              <a:rPr lang="en-US" sz="2850" dirty="0" spc="-16" kern="0">
+              <a:t> tự:</a:t>
+            </a:r>
+            <a:r>
+              <a:rPr lang="en-US" sz="2850" dirty="0" spc="1" kern="0">
                 <a:solidFill>
                   <a:srgbClr val="F3EEE3"/>
                 </a:solidFill>
@@ -13526,7 +13361,29 @@
                 <a:ea typeface="Be Vietnam Pro" pitchFamily="34" charset="-122"/>
                 <a:cs typeface="Be Vietnam Pro" pitchFamily="34" charset="-120"/>
               </a:rPr>
-              <a:t> mất</a:t>
+              <a:t> hỏi</a:t>
+            </a:r>
+            <a:r>
+              <a:rPr lang="en-US" sz="2850" dirty="0" spc="-4" kern="0">
+                <a:solidFill>
+                  <a:srgbClr val="F3EEE3"/>
+                </a:solidFill>
+                <a:latin typeface="Be Vietnam Pro" pitchFamily="34" charset="0"/>
+                <a:ea typeface="Be Vietnam Pro" pitchFamily="34" charset="-122"/>
+                <a:cs typeface="Be Vietnam Pro" pitchFamily="34" charset="-120"/>
+              </a:rPr>
+              <a:t> theo</a:t>
+            </a:r>
+            <a:r>
+              <a:rPr lang="en-US" sz="2850" dirty="0" spc="-3" kern="0">
+                <a:solidFill>
+                  <a:srgbClr val="F3EEE3"/>
+                </a:solidFill>
+                <a:latin typeface="Be Vietnam Pro" pitchFamily="34" charset="0"/>
+                <a:ea typeface="Be Vietnam Pro" pitchFamily="34" charset="-122"/>
+                <a:cs typeface="Be Vietnam Pro" pitchFamily="34" charset="-120"/>
+              </a:rPr>
+              <a:t> khoảng</a:t>
             </a:r>
             <a:r>
               <a:rPr lang="en-US" sz="2850" dirty="0" spc="-1" kern="0">
@@ -13537,7 +13394,7 @@
                 <a:ea typeface="Be Vietnam Pro" pitchFamily="34" charset="-122"/>
                 <a:cs typeface="Be Vietnam Pro" pitchFamily="34" charset="-120"/>
               </a:rPr>
-              <a:t> thứ</a:t>
+              <a:t> chạm</a:t>
             </a:r>
             <a:r>
               <a:rPr lang="en-US" sz="2850" dirty="0" spc="0" kern="0">
@@ -13548,40 +13405,7 @@
                 <a:ea typeface="Be Vietnam Pro" pitchFamily="34" charset="-122"/>
                 <a:cs typeface="Be Vietnam Pro" pitchFamily="34" charset="-120"/>
               </a:rPr>
-              <a:t> tự:</a:t>
-            </a:r>
-            <a:r>
-              <a:rPr lang="en-US" sz="2850" dirty="0" spc="1" kern="0">
-                <a:solidFill>
-                  <a:srgbClr val="F3EEE3"/>
-                </a:solidFill>
-                <a:latin typeface="Be Vietnam Pro" pitchFamily="34" charset="0"/>
-                <a:ea typeface="Be Vietnam Pro" pitchFamily="34" charset="-122"/>
-                <a:cs typeface="Be Vietnam Pro" pitchFamily="34" charset="-120"/>
-              </a:rPr>
-              <a:t> hỏi</a:t>
-            </a:r>
-            <a:r>
-              <a:rPr lang="en-US" sz="2850" dirty="0" spc="-3" kern="0">
-                <a:solidFill>
-                  <a:srgbClr val="F3EEE3"/>
-                </a:solidFill>
-                <a:latin typeface="Be Vietnam Pro" pitchFamily="34" charset="0"/>
-                <a:ea typeface="Be Vietnam Pro" pitchFamily="34" charset="-122"/>
-                <a:cs typeface="Be Vietnam Pro" pitchFamily="34" charset="-120"/>
-              </a:rPr>
-              <a:t> theo khoảng</a:t>
-            </a:r>
-            <a:r>
-              <a:rPr lang="en-US" sz="2850" dirty="0" spc="-1" kern="0">
-                <a:solidFill>
-                  <a:srgbClr val="F3EEE3"/>
-                </a:solidFill>
-                <a:latin typeface="Be Vietnam Pro" pitchFamily="34" charset="0"/>
-                <a:ea typeface="Be Vietnam Pro" pitchFamily="34" charset="-122"/>
-                <a:cs typeface="Be Vietnam Pro" pitchFamily="34" charset="-120"/>
-              </a:rPr>
-              <a:t> chạm mọi</a:t>
+              <a:t> mọi</a:t>
             </a:r>
             <a:r>
               <a:rPr lang="en-US" sz="2850" dirty="0" spc="-15" kern="0">
@@ -13697,10 +13521,10 @@
                 <a:ea typeface="Be Vietnam Pro" pitchFamily="34" charset="-122"/>
                 <a:cs typeface="Be Vietnam Pro" pitchFamily="34" charset="-120"/>
               </a:rPr>
-              <a:t> cần hàm</a:t>
-            </a:r>
-            <a:r>
-              <a:rPr lang="en-US" sz="2850" dirty="0" spc="-4" kern="0">
+              <a:t> cần</a:t>
+            </a:r>
+            <a:r>
+              <a:rPr lang="en-US" sz="2850" dirty="0" spc="-5" kern="0">
                 <a:solidFill>
                   <a:srgbClr val="F3EEE3"/>
                 </a:solidFill>

</xml_diff>

<commit_message>
Slides: cover titles at 108 px, slide titles at 92 px (sd-04-025..029)
The cover title of each deck is now 108 px and every slide title is
92 to 112 px, as docs/sd101-slides.md sets; two titles were shortened
to stay on one line. PPTX files re-exported from the canvases.

Co-Authored-By: Claude Opus 5.5 <noreply@anthropic.com>
Claude-Session: https://claude.ai/code/session_01JWtUsCyy9ESaq4agyTKnFb
</commit_message>
<xml_diff>
--- a/system-design-101/vi/lessons/sd-04-025/slides/sd-04-025.pptx
+++ b/system-design-101/vi/lessons/sd-04-025/slides/sd-04-025.pptx
@@ -1790,7 +1790,7 @@
         <p:spPr>
           <a:xfrm>
             <a:off x="914400" y="1428750"/>
-            <a:ext cx="9144000" cy="2657475"/>
+            <a:ext cx="9334500" cy="2286000"/>
           </a:xfrm>
           <a:prstGeom prst="rect">
             <a:avLst/>
@@ -1799,17 +1799,17 @@
           <a:ln/>
         </p:spPr>
         <p:txBody>
-          <a:bodyPr wrap="square" lIns="0" tIns="61722" rIns="0" bIns="-61722" rtlCol="0" anchor="t"/>
+          <a:bodyPr wrap="square" lIns="0" tIns="69437" rIns="0" bIns="-69437" rtlCol="0" anchor="t"/>
           <a:lstStyle/>
           <a:p>
             <a:pPr algn="l" indent="0" marL="0">
               <a:lnSpc>
-                <a:spcPts val="7560"/>
+                <a:spcPts val="8505"/>
               </a:lnSpc>
               <a:buNone/>
             </a:pPr>
             <a:r>
-              <a:rPr lang="en-US" sz="7200" dirty="0" spc="-2" kern="0">
+              <a:rPr lang="en-US" sz="8100" dirty="0" spc="2" kern="0">
                 <a:solidFill>
                   <a:srgbClr val="F3EEE3"/>
                 </a:solidFill>
@@ -1817,10 +1817,10 @@
                 <a:ea typeface="Bricolage Grotesque ExtraBold" pitchFamily="34" charset="-122"/>
                 <a:cs typeface="Bricolage Grotesque ExtraBold" pitchFamily="34" charset="-120"/>
               </a:rPr>
-              <a:t>Bốn</a:t>
-            </a:r>
-            <a:r>
-              <a:rPr lang="en-US" sz="7200" dirty="0" spc="2" kern="0">
+              <a:t>Bốn cách</a:t>
+            </a:r>
+            <a:r>
+              <a:rPr lang="en-US" sz="8100" dirty="0" spc="-1" kern="0">
                 <a:solidFill>
                   <a:srgbClr val="F3EEE3"/>
                 </a:solidFill>
@@ -1828,10 +1828,10 @@
                 <a:ea typeface="Bricolage Grotesque ExtraBold" pitchFamily="34" charset="-122"/>
                 <a:cs typeface="Bricolage Grotesque ExtraBold" pitchFamily="34" charset="-120"/>
               </a:rPr>
-              <a:t> cách</a:t>
-            </a:r>
-            <a:r>
-              <a:rPr lang="en-US" sz="7200" dirty="0" spc="-1" kern="0">
+              <a:t> chia dữ</a:t>
+            </a:r>
+            <a:r>
+              <a:rPr lang="en-US" sz="8100" dirty="0" spc="2" kern="0">
                 <a:solidFill>
                   <a:srgbClr val="F3EEE3"/>
                 </a:solidFill>
@@ -1839,10 +1839,10 @@
                 <a:ea typeface="Bricolage Grotesque ExtraBold" pitchFamily="34" charset="-122"/>
                 <a:cs typeface="Bricolage Grotesque ExtraBold" pitchFamily="34" charset="-120"/>
               </a:rPr>
-              <a:t> chia</a:t>
-            </a:r>
-            <a:r>
-              <a:rPr lang="en-US" sz="7200" dirty="0" spc="0" kern="0">
+              <a:t> liệu</a:t>
+            </a:r>
+            <a:r>
+              <a:rPr lang="en-US" sz="8100" dirty="0" spc="-64" kern="0">
                 <a:solidFill>
                   <a:srgbClr val="F3EEE3"/>
                 </a:solidFill>
@@ -1850,10 +1850,10 @@
                 <a:ea typeface="Bricolage Grotesque ExtraBold" pitchFamily="34" charset="-122"/>
                 <a:cs typeface="Bricolage Grotesque ExtraBold" pitchFamily="34" charset="-120"/>
               </a:rPr>
-              <a:t> dữ</a:t>
-            </a:r>
-            <a:r>
-              <a:rPr lang="en-US" sz="7200" dirty="0" spc="4" kern="0">
+              <a:t> vào</a:t>
+            </a:r>
+            <a:r>
+              <a:rPr lang="en-US" sz="8100" dirty="0" spc="-11" kern="0">
                 <a:solidFill>
                   <a:srgbClr val="F3EEE3"/>
                 </a:solidFill>
@@ -1861,31 +1861,9 @@
                 <a:ea typeface="Bricolage Grotesque ExtraBold" pitchFamily="34" charset="-122"/>
                 <a:cs typeface="Bricolage Grotesque ExtraBold" pitchFamily="34" charset="-120"/>
               </a:rPr>
-              <a:t> liệu</a:t>
-            </a:r>
-            <a:r>
-              <a:rPr lang="en-US" sz="7200" dirty="0" spc="-59" kern="0">
-                <a:solidFill>
-                  <a:srgbClr val="F3EEE3"/>
-                </a:solidFill>
-                <a:latin typeface="Bricolage Grotesque ExtraBold" pitchFamily="34" charset="0"/>
-                <a:ea typeface="Bricolage Grotesque ExtraBold" pitchFamily="34" charset="-122"/>
-                <a:cs typeface="Bricolage Grotesque ExtraBold" pitchFamily="34" charset="-120"/>
-              </a:rPr>
-              <a:t> vào</a:t>
-            </a:r>
-            <a:r>
-              <a:rPr lang="en-US" sz="7200" dirty="0" spc="-11" kern="0">
-                <a:solidFill>
-                  <a:srgbClr val="F3EEE3"/>
-                </a:solidFill>
-                <a:latin typeface="Bricolage Grotesque ExtraBold" pitchFamily="34" charset="0"/>
-                <a:ea typeface="Bricolage Grotesque ExtraBold" pitchFamily="34" charset="-122"/>
-                <a:cs typeface="Bricolage Grotesque ExtraBold" pitchFamily="34" charset="-120"/>
-              </a:rPr>
               <a:t> shard</a:t>
             </a:r>
-            <a:endParaRPr lang="en-US" sz="7200" dirty="0"/>
+            <a:endParaRPr lang="en-US" sz="8100" dirty="0"/>
           </a:p>
         </p:txBody>
       </p:sp>
@@ -1897,7 +1875,7 @@
         </p:nvSpPr>
         <p:spPr>
           <a:xfrm>
-            <a:off x="914400" y="3810000"/>
+            <a:off x="914400" y="3905250"/>
             <a:ext cx="8572500" cy="1047750"/>
           </a:xfrm>
           <a:prstGeom prst="rect">
@@ -14097,7 +14075,7 @@
         <p:spPr>
           <a:xfrm>
             <a:off x="914400" y="1333500"/>
-            <a:ext cx="16459200" cy="1990725"/>
+            <a:ext cx="16459200" cy="2000250"/>
           </a:xfrm>
           <a:prstGeom prst="rect">
             <a:avLst/>
@@ -14106,17 +14084,17 @@
           <a:ln/>
         </p:spPr>
         <p:txBody>
-          <a:bodyPr wrap="square" lIns="0" tIns="41910" rIns="0" bIns="-41910" rtlCol="0" anchor="t"/>
+          <a:bodyPr wrap="square" lIns="0" tIns="43815" rIns="0" bIns="-43815" rtlCol="0" anchor="t"/>
           <a:lstStyle/>
           <a:p>
             <a:pPr algn="l" indent="0" marL="0">
               <a:lnSpc>
-                <a:spcPts val="7260"/>
+                <a:spcPts val="7590"/>
               </a:lnSpc>
               <a:buNone/>
             </a:pPr>
             <a:r>
-              <a:rPr lang="en-US" sz="6600" dirty="0" spc="-50" kern="0">
+              <a:rPr lang="en-US" sz="6900" dirty="0" spc="-59" kern="0">
                 <a:solidFill>
                   <a:srgbClr val="14161C"/>
                 </a:solidFill>
@@ -14127,7 +14105,7 @@
               <a:t>Từ</a:t>
             </a:r>
             <a:r>
-              <a:rPr lang="en-US" sz="6600" dirty="0" spc="1" kern="0">
+              <a:rPr lang="en-US" sz="6900" dirty="0" spc="-2" kern="0">
                 <a:solidFill>
                   <a:srgbClr val="14161C"/>
                 </a:solidFill>
@@ -14138,7 +14116,7 @@
               <a:t> 8</a:t>
             </a:r>
             <a:r>
-              <a:rPr lang="en-US" sz="6600" dirty="0" spc="0" kern="0">
+              <a:rPr lang="en-US" sz="6900" dirty="0" spc="6" kern="0">
                 <a:solidFill>
                   <a:srgbClr val="14161C"/>
                 </a:solidFill>
@@ -14149,7 +14127,7 @@
               <a:t> lên</a:t>
             </a:r>
             <a:r>
-              <a:rPr lang="en-US" sz="6600" dirty="0" spc="4" kern="0">
+              <a:rPr lang="en-US" sz="6900" dirty="0" spc="0" kern="0">
                 <a:solidFill>
                   <a:srgbClr val="14161C"/>
                 </a:solidFill>
@@ -14160,7 +14138,7 @@
               <a:t> 9</a:t>
             </a:r>
             <a:r>
-              <a:rPr lang="en-US" sz="6600" dirty="0" spc="-9" kern="0">
+              <a:rPr lang="en-US" sz="6900" dirty="0" spc="-9" kern="0">
                 <a:solidFill>
                   <a:srgbClr val="14161C"/>
                 </a:solidFill>
@@ -14171,7 +14149,7 @@
               <a:t> shard</a:t>
             </a:r>
             <a:r>
-              <a:rPr lang="en-US" sz="6600" dirty="0" spc="-3" kern="0">
+              <a:rPr lang="en-US" sz="6900" dirty="0" spc="-1" kern="0">
                 <a:solidFill>
                   <a:srgbClr val="14161C"/>
                 </a:solidFill>
@@ -14182,7 +14160,7 @@
               <a:t> chia</a:t>
             </a:r>
             <a:r>
-              <a:rPr lang="en-US" sz="6600" dirty="0" spc="-28" kern="0">
+              <a:rPr lang="en-US" sz="6900" dirty="0" spc="-32" kern="0">
                 <a:solidFill>
                   <a:srgbClr val="14161C"/>
                 </a:solidFill>
@@ -14193,7 +14171,7 @@
               <a:t> dư:</a:t>
             </a:r>
             <a:r>
-              <a:rPr lang="en-US" sz="6600" dirty="0" spc="-1" kern="0">
+              <a:rPr lang="en-US" sz="6900" dirty="0" spc="3" kern="0">
                 <a:solidFill>
                   <a:srgbClr val="14161C"/>
                 </a:solidFill>
@@ -14204,7 +14182,7 @@
               <a:t> chuyển</a:t>
             </a:r>
             <a:r>
-              <a:rPr lang="en-US" sz="6600" dirty="0" spc="-2" kern="0">
+              <a:rPr lang="en-US" sz="6900" dirty="0" spc="-4" kern="0">
                 <a:solidFill>
                   <a:srgbClr val="14161C"/>
                 </a:solidFill>
@@ -14215,7 +14193,7 @@
               <a:t> bao</a:t>
             </a:r>
             <a:r>
-              <a:rPr lang="en-US" sz="6600" dirty="0" spc="-1" kern="0">
+              <a:rPr lang="en-US" sz="6900" dirty="0" spc="3" kern="0">
                 <a:solidFill>
                   <a:srgbClr val="14161C"/>
                 </a:solidFill>
@@ -14225,7 +14203,7 @@
               </a:rPr>
               <a:t> nhiêu?</a:t>
             </a:r>
-            <a:endParaRPr lang="en-US" sz="6600" dirty="0"/>
+            <a:endParaRPr lang="en-US" sz="6900" dirty="0"/>
           </a:p>
         </p:txBody>
       </p:sp>

</xml_diff>

<commit_message>
Slides: badged PPTX of sd-04-025
</commit_message>
<xml_diff>
--- a/system-design-101/vi/lessons/sd-04-025/slides/sd-04-025.pptx
+++ b/system-design-101/vi/lessons/sd-04-025/slides/sd-04-025.pptx
@@ -5054,109 +5054,65 @@
                 <a:ea typeface="Be Vietnam Pro" pitchFamily="34" charset="-122"/>
                 <a:cs typeface="Be Vietnam Pro" pitchFamily="34" charset="-120"/>
               </a:rPr>
-              <a:t>100.000</a:t>
+              <a:t>100.000 id, 4</a:t>
+            </a:r>
+            <a:r>
+              <a:rPr lang="en-US" sz="2700" dirty="0" spc="-3" kern="0">
+                <a:solidFill>
+                  <a:srgbClr val="14161C"/>
+                </a:solidFill>
+                <a:latin typeface="Be Vietnam Pro" pitchFamily="34" charset="0"/>
+                <a:ea typeface="Be Vietnam Pro" pitchFamily="34" charset="-122"/>
+                <a:cs typeface="Be Vietnam Pro" pitchFamily="34" charset="-120"/>
+              </a:rPr>
+              <a:t> lên</a:t>
+            </a:r>
+            <a:r>
+              <a:rPr lang="en-US" sz="2700" dirty="0" spc="-4" kern="0">
+                <a:solidFill>
+                  <a:srgbClr val="14161C"/>
+                </a:solidFill>
+                <a:latin typeface="Be Vietnam Pro" pitchFamily="34" charset="0"/>
+                <a:ea typeface="Be Vietnam Pro" pitchFamily="34" charset="-122"/>
+                <a:cs typeface="Be Vietnam Pro" pitchFamily="34" charset="-120"/>
+              </a:rPr>
+              <a:t> 5</a:t>
+            </a:r>
+            <a:r>
+              <a:rPr lang="en-US" sz="2700" dirty="0" spc="-17" kern="0">
+                <a:solidFill>
+                  <a:srgbClr val="14161C"/>
+                </a:solidFill>
+                <a:latin typeface="Be Vietnam Pro" pitchFamily="34" charset="0"/>
+                <a:ea typeface="Be Vietnam Pro" pitchFamily="34" charset="-122"/>
+                <a:cs typeface="Be Vietnam Pro" pitchFamily="34" charset="-120"/>
+              </a:rPr>
+              <a:t> shard,</a:t>
+            </a:r>
+            <a:r>
+              <a:rPr lang="en-US" sz="2700" dirty="0" spc="10" kern="0">
+                <a:solidFill>
+                  <a:srgbClr val="14161C"/>
+                </a:solidFill>
+                <a:latin typeface="Be Vietnam Pro" pitchFamily="34" charset="0"/>
+                <a:ea typeface="Be Vietnam Pro" pitchFamily="34" charset="-122"/>
+                <a:cs typeface="Be Vietnam Pro" pitchFamily="34" charset="-120"/>
+              </a:rPr>
+              <a:t> đếm</a:t>
+            </a:r>
+            <a:r>
+              <a:rPr lang="en-US" sz="2700" dirty="0" spc="-5" kern="0">
+                <a:solidFill>
+                  <a:srgbClr val="14161C"/>
+                </a:solidFill>
+                <a:latin typeface="Be Vietnam Pro" pitchFamily="34" charset="0"/>
+                <a:ea typeface="Be Vietnam Pro" pitchFamily="34" charset="-122"/>
+                <a:cs typeface="Be Vietnam Pro" pitchFamily="34" charset="-120"/>
+              </a:rPr>
+              <a:t> khóa</a:t>
             </a:r>
             <a:r>
               <a:rPr lang="en-US" sz="2700" dirty="0" spc="-2" kern="0">
-                <a:solidFill>
-                  <a:srgbClr val="14161C"/>
-                </a:solidFill>
-                <a:latin typeface="Be Vietnam Pro" pitchFamily="34" charset="0"/>
-                <a:ea typeface="Be Vietnam Pro" pitchFamily="34" charset="-122"/>
-                <a:cs typeface="Be Vietnam Pro" pitchFamily="34" charset="-120"/>
-              </a:rPr>
-              <a:t> id</a:t>
-            </a:r>
-            <a:r>
-              <a:rPr lang="en-US" sz="2700" dirty="0" spc="-1" kern="0">
-                <a:solidFill>
-                  <a:srgbClr val="14161C"/>
-                </a:solidFill>
-                <a:latin typeface="Be Vietnam Pro" pitchFamily="34" charset="0"/>
-                <a:ea typeface="Be Vietnam Pro" pitchFamily="34" charset="-122"/>
-                <a:cs typeface="Be Vietnam Pro" pitchFamily="34" charset="-120"/>
-              </a:rPr>
-              <a:t> · từ</a:t>
-            </a:r>
-            <a:r>
-              <a:rPr lang="en-US" sz="2700" dirty="0" spc="0" kern="0">
-                <a:solidFill>
-                  <a:srgbClr val="14161C"/>
-                </a:solidFill>
-                <a:latin typeface="Be Vietnam Pro" pitchFamily="34" charset="0"/>
-                <a:ea typeface="Be Vietnam Pro" pitchFamily="34" charset="-122"/>
-                <a:cs typeface="Be Vietnam Pro" pitchFamily="34" charset="-120"/>
-              </a:rPr>
-              <a:t> 4</a:t>
-            </a:r>
-            <a:r>
-              <a:rPr lang="en-US" sz="2700" dirty="0" spc="-3" kern="0">
-                <a:solidFill>
-                  <a:srgbClr val="14161C"/>
-                </a:solidFill>
-                <a:latin typeface="Be Vietnam Pro" pitchFamily="34" charset="0"/>
-                <a:ea typeface="Be Vietnam Pro" pitchFamily="34" charset="-122"/>
-                <a:cs typeface="Be Vietnam Pro" pitchFamily="34" charset="-120"/>
-              </a:rPr>
-              <a:t> lên</a:t>
-            </a:r>
-            <a:r>
-              <a:rPr lang="en-US" sz="2700" dirty="0" spc="-4" kern="0">
-                <a:solidFill>
-                  <a:srgbClr val="14161C"/>
-                </a:solidFill>
-                <a:latin typeface="Be Vietnam Pro" pitchFamily="34" charset="0"/>
-                <a:ea typeface="Be Vietnam Pro" pitchFamily="34" charset="-122"/>
-                <a:cs typeface="Be Vietnam Pro" pitchFamily="34" charset="-120"/>
-              </a:rPr>
-              <a:t> 5</a:t>
-            </a:r>
-            <a:r>
-              <a:rPr lang="en-US" sz="2700" dirty="0" spc="-21" kern="0">
-                <a:solidFill>
-                  <a:srgbClr val="14161C"/>
-                </a:solidFill>
-                <a:latin typeface="Be Vietnam Pro" pitchFamily="34" charset="0"/>
-                <a:ea typeface="Be Vietnam Pro" pitchFamily="34" charset="-122"/>
-                <a:cs typeface="Be Vietnam Pro" pitchFamily="34" charset="-120"/>
-              </a:rPr>
-              <a:t> shard</a:t>
-            </a:r>
-            <a:r>
-              <a:rPr lang="en-US" sz="2700" dirty="0" spc="-2" kern="0">
-                <a:solidFill>
-                  <a:srgbClr val="14161C"/>
-                </a:solidFill>
-                <a:latin typeface="Be Vietnam Pro" pitchFamily="34" charset="0"/>
-                <a:ea typeface="Be Vietnam Pro" pitchFamily="34" charset="-122"/>
-                <a:cs typeface="Be Vietnam Pro" pitchFamily="34" charset="-120"/>
-              </a:rPr>
-              <a:t> ·</a:t>
-            </a:r>
-            <a:r>
-              <a:rPr lang="en-US" sz="2700" dirty="0" spc="11" kern="0">
-                <a:solidFill>
-                  <a:srgbClr val="14161C"/>
-                </a:solidFill>
-                <a:latin typeface="Be Vietnam Pro" pitchFamily="34" charset="0"/>
-                <a:ea typeface="Be Vietnam Pro" pitchFamily="34" charset="-122"/>
-                <a:cs typeface="Be Vietnam Pro" pitchFamily="34" charset="-120"/>
-              </a:rPr>
-              <a:t> đếm</a:t>
-            </a:r>
-            <a:r>
-              <a:rPr lang="en-US" sz="2700" dirty="0" spc="-6" kern="0">
-                <a:solidFill>
-                  <a:srgbClr val="14161C"/>
-                </a:solidFill>
-                <a:latin typeface="Be Vietnam Pro" pitchFamily="34" charset="0"/>
-                <a:ea typeface="Be Vietnam Pro" pitchFamily="34" charset="-122"/>
-                <a:cs typeface="Be Vietnam Pro" pitchFamily="34" charset="-120"/>
-              </a:rPr>
-              <a:t> khóa</a:t>
-            </a:r>
-            <a:r>
-              <a:rPr lang="en-US" sz="2700" dirty="0" spc="-1" kern="0">
                 <a:solidFill>
                   <a:srgbClr val="14161C"/>
                 </a:solidFill>

</xml_diff>